<commit_message>
End the line where a:br stands
Co-Authored-By: Claude Opus 5 <noreply@anthropic.com>
Signed-off-by: RyujiYasukochi <ryuji.yasu@gmail.com>
</commit_message>
<xml_diff>
--- a/tests/fixtures/highlight_test.pptx
+++ b/tests/fixtures/highlight_test.pptx
@@ -3141,6 +3141,17 @@
                 </a:highlight>
               </a:rPr>
               <a:t>start</a:t>
+            </a:r>
+            <a:br>
+              <a:rPr lang="en-US" sz="1800"/>
+            </a:br>
+            <a:r>
+              <a:rPr lang="en-US" sz="1800">
+                <a:solidFill>
+                  <a:srgbClr val="445566"/>
+                </a:solidFill>
+              </a:rPr>
+              <a:t>after the break</a:t>
             </a:r>
           </a:p>
         </p:txBody>

</xml_diff>